<commit_message>
2025 updates to slides and a check that the script still works.
</commit_message>
<xml_diff>
--- a/Presentations/Survival task.pptx
+++ b/Presentations/Survival task.pptx
@@ -111,6 +111,11 @@
       </a:defRPr>
     </a:lvl9pPr>
   </p:defaultTextStyle>
+  <p:extLst>
+    <p:ext uri="{EFAFB233-063F-42B5-8137-9DF3F51BA10A}">
+      <p15:sldGuideLst xmlns:p15="http://schemas.microsoft.com/office/powerpoint/2012/main"/>
+    </p:ext>
+  </p:extLst>
 </p:presentation>
 </file>
 
@@ -196,7 +201,7 @@
           <a:p>
             <a:fld id="{9D8D4722-2590-3B46-B5A4-BC75C1AFA143}" type="datetimeFigureOut">
               <a:rPr lang="en-GB" smtClean="0"/>
-              <a:t>25/09/2023</a:t>
+              <a:t>26/06/2025</a:t>
             </a:fld>
             <a:endParaRPr lang="en-GB"/>
           </a:p>
@@ -795,7 +800,7 @@
           <a:p>
             <a:fld id="{631F568A-094F-3B49-8C1C-57CE1E225C7B}" type="datetimeFigureOut">
               <a:rPr lang="en-GB" smtClean="0"/>
-              <a:t>25/09/2023</a:t>
+              <a:t>26/06/2025</a:t>
             </a:fld>
             <a:endParaRPr lang="en-GB"/>
           </a:p>
@@ -993,7 +998,7 @@
           <a:p>
             <a:fld id="{631F568A-094F-3B49-8C1C-57CE1E225C7B}" type="datetimeFigureOut">
               <a:rPr lang="en-GB" smtClean="0"/>
-              <a:t>25/09/2023</a:t>
+              <a:t>26/06/2025</a:t>
             </a:fld>
             <a:endParaRPr lang="en-GB"/>
           </a:p>
@@ -1201,7 +1206,7 @@
           <a:p>
             <a:fld id="{631F568A-094F-3B49-8C1C-57CE1E225C7B}" type="datetimeFigureOut">
               <a:rPr lang="en-GB" smtClean="0"/>
-              <a:t>25/09/2023</a:t>
+              <a:t>26/06/2025</a:t>
             </a:fld>
             <a:endParaRPr lang="en-GB"/>
           </a:p>
@@ -1399,7 +1404,7 @@
           <a:p>
             <a:fld id="{631F568A-094F-3B49-8C1C-57CE1E225C7B}" type="datetimeFigureOut">
               <a:rPr lang="en-GB" smtClean="0"/>
-              <a:t>25/09/2023</a:t>
+              <a:t>26/06/2025</a:t>
             </a:fld>
             <a:endParaRPr lang="en-GB"/>
           </a:p>
@@ -1674,7 +1679,7 @@
           <a:p>
             <a:fld id="{631F568A-094F-3B49-8C1C-57CE1E225C7B}" type="datetimeFigureOut">
               <a:rPr lang="en-GB" smtClean="0"/>
-              <a:t>25/09/2023</a:t>
+              <a:t>26/06/2025</a:t>
             </a:fld>
             <a:endParaRPr lang="en-GB"/>
           </a:p>
@@ -1939,7 +1944,7 @@
           <a:p>
             <a:fld id="{631F568A-094F-3B49-8C1C-57CE1E225C7B}" type="datetimeFigureOut">
               <a:rPr lang="en-GB" smtClean="0"/>
-              <a:t>25/09/2023</a:t>
+              <a:t>26/06/2025</a:t>
             </a:fld>
             <a:endParaRPr lang="en-GB"/>
           </a:p>
@@ -2351,7 +2356,7 @@
           <a:p>
             <a:fld id="{631F568A-094F-3B49-8C1C-57CE1E225C7B}" type="datetimeFigureOut">
               <a:rPr lang="en-GB" smtClean="0"/>
-              <a:t>25/09/2023</a:t>
+              <a:t>26/06/2025</a:t>
             </a:fld>
             <a:endParaRPr lang="en-GB"/>
           </a:p>
@@ -2492,7 +2497,7 @@
           <a:p>
             <a:fld id="{631F568A-094F-3B49-8C1C-57CE1E225C7B}" type="datetimeFigureOut">
               <a:rPr lang="en-GB" smtClean="0"/>
-              <a:t>25/09/2023</a:t>
+              <a:t>26/06/2025</a:t>
             </a:fld>
             <a:endParaRPr lang="en-GB"/>
           </a:p>
@@ -2605,7 +2610,7 @@
           <a:p>
             <a:fld id="{631F568A-094F-3B49-8C1C-57CE1E225C7B}" type="datetimeFigureOut">
               <a:rPr lang="en-GB" smtClean="0"/>
-              <a:t>25/09/2023</a:t>
+              <a:t>26/06/2025</a:t>
             </a:fld>
             <a:endParaRPr lang="en-GB"/>
           </a:p>
@@ -2916,7 +2921,7 @@
           <a:p>
             <a:fld id="{631F568A-094F-3B49-8C1C-57CE1E225C7B}" type="datetimeFigureOut">
               <a:rPr lang="en-GB" smtClean="0"/>
-              <a:t>25/09/2023</a:t>
+              <a:t>26/06/2025</a:t>
             </a:fld>
             <a:endParaRPr lang="en-GB"/>
           </a:p>
@@ -3204,7 +3209,7 @@
           <a:p>
             <a:fld id="{631F568A-094F-3B49-8C1C-57CE1E225C7B}" type="datetimeFigureOut">
               <a:rPr lang="en-GB" smtClean="0"/>
-              <a:t>25/09/2023</a:t>
+              <a:t>26/06/2025</a:t>
             </a:fld>
             <a:endParaRPr lang="en-GB"/>
           </a:p>
@@ -3445,7 +3450,7 @@
           <a:p>
             <a:fld id="{631F568A-094F-3B49-8C1C-57CE1E225C7B}" type="datetimeFigureOut">
               <a:rPr lang="en-GB" smtClean="0"/>
-              <a:t>25/09/2023</a:t>
+              <a:t>26/06/2025</a:t>
             </a:fld>
             <a:endParaRPr lang="en-GB"/>
           </a:p>
@@ -3935,19 +3940,12 @@
               <a:rPr lang="en-GB" dirty="0">
                 <a:hlinkClick r:id="rId3"/>
               </a:rPr>
-              <a:t>https://www.youtube.com/watch?v=t6vdjwhauF8&amp;t</a:t>
-            </a:r>
-            <a:r>
-              <a:rPr lang="en-GB">
-                <a:hlinkClick r:id="rId3"/>
-              </a:rPr>
-              <a:t>=201s</a:t>
-            </a:r>
-            <a:r>
-              <a:rPr lang="en-GB"/>
+              <a:t>https://www.youtube.com/watch?v=t6vdjwhauF8&amp;t=201s</a:t>
+            </a:r>
+            <a:r>
+              <a:rPr lang="en-GB" dirty="0"/>
               <a:t> </a:t>
             </a:r>
-            <a:endParaRPr lang="en-GB" dirty="0"/>
           </a:p>
         </p:txBody>
       </p:sp>
@@ -4032,7 +4030,7 @@
           <a:p>
             <a:r>
               <a:rPr lang="en-GB" dirty="0"/>
-              <a:t>MMB masterclass 2023</a:t>
+              <a:t>MMB masterclass 2025</a:t>
             </a:r>
           </a:p>
         </p:txBody>
@@ -4241,9 +4239,21 @@
                   <a:srgbClr val="333333"/>
                 </a:solidFill>
                 <a:effectLst/>
-                <a:latin typeface="STIXGeneral-Italic" pitchFamily="2" charset="2"/>
+                <a:latin typeface="Arial" panose="020B0604020202020204" pitchFamily="34" charset="0"/>
+                <a:cs typeface="Arial" panose="020B0604020202020204" pitchFamily="34" charset="0"/>
               </a:rPr>
-              <a:t>log</a:t>
+              <a:t>log(h(t))=log(h</a:t>
+            </a:r>
+            <a:r>
+              <a:rPr lang="en-GB" b="0" i="0" u="none" strike="noStrike" baseline="-25000" dirty="0">
+                <a:solidFill>
+                  <a:srgbClr val="333333"/>
+                </a:solidFill>
+                <a:effectLst/>
+                <a:latin typeface="Arial" panose="020B0604020202020204" pitchFamily="34" charset="0"/>
+                <a:cs typeface="Arial" panose="020B0604020202020204" pitchFamily="34" charset="0"/>
+              </a:rPr>
+              <a:t>0</a:t>
             </a:r>
             <a:r>
               <a:rPr lang="en-GB" b="0" i="0" u="none" strike="noStrike" dirty="0">
@@ -4251,9 +4261,32 @@
                   <a:srgbClr val="333333"/>
                 </a:solidFill>
                 <a:effectLst/>
-                <a:latin typeface="STIXGeneral-Regular" pitchFamily="2" charset="2"/>
+                <a:latin typeface="Arial" panose="020B0604020202020204" pitchFamily="34" charset="0"/>
+                <a:cs typeface="Arial" panose="020B0604020202020204" pitchFamily="34" charset="0"/>
               </a:rPr>
-              <a:t>(</a:t>
+              <a:t>(t))+</a:t>
+            </a:r>
+            <a:r>
+              <a:rPr lang="el-GR" b="0" i="0" u="none" strike="noStrike" dirty="0">
+                <a:solidFill>
+                  <a:srgbClr val="333333"/>
+                </a:solidFill>
+                <a:effectLst/>
+                <a:latin typeface="Arial" panose="020B0604020202020204" pitchFamily="34" charset="0"/>
+                <a:cs typeface="Arial" panose="020B0604020202020204" pitchFamily="34" charset="0"/>
+              </a:rPr>
+              <a:t>β</a:t>
+            </a:r>
+            <a:r>
+              <a:rPr lang="el-GR" b="0" i="0" u="none" strike="noStrike" baseline="-25000" dirty="0">
+                <a:solidFill>
+                  <a:srgbClr val="333333"/>
+                </a:solidFill>
+                <a:effectLst/>
+                <a:latin typeface="Arial" panose="020B0604020202020204" pitchFamily="34" charset="0"/>
+                <a:cs typeface="Arial" panose="020B0604020202020204" pitchFamily="34" charset="0"/>
+              </a:rPr>
+              <a:t>1</a:t>
             </a:r>
             <a:r>
               <a:rPr lang="en-GB" b="0" i="0" u="none" strike="noStrike" dirty="0">
@@ -4261,9 +4294,21 @@
                   <a:srgbClr val="333333"/>
                 </a:solidFill>
                 <a:effectLst/>
-                <a:latin typeface="STIXGeneral-Italic" pitchFamily="2" charset="2"/>
+                <a:latin typeface="Arial" panose="020B0604020202020204" pitchFamily="34" charset="0"/>
+                <a:cs typeface="Arial" panose="020B0604020202020204" pitchFamily="34" charset="0"/>
               </a:rPr>
-              <a:t>h</a:t>
+              <a:t>x</a:t>
+            </a:r>
+            <a:r>
+              <a:rPr lang="en-GB" b="0" i="0" u="none" strike="noStrike" baseline="-25000" dirty="0">
+                <a:solidFill>
+                  <a:srgbClr val="333333"/>
+                </a:solidFill>
+                <a:effectLst/>
+                <a:latin typeface="Arial" panose="020B0604020202020204" pitchFamily="34" charset="0"/>
+                <a:cs typeface="Arial" panose="020B0604020202020204" pitchFamily="34" charset="0"/>
+              </a:rPr>
+              <a:t>1</a:t>
             </a:r>
             <a:r>
               <a:rPr lang="en-GB" b="0" i="0" u="none" strike="noStrike" dirty="0">
@@ -4271,9 +4316,32 @@
                   <a:srgbClr val="333333"/>
                 </a:solidFill>
                 <a:effectLst/>
-                <a:latin typeface="STIXGeneral-Regular" pitchFamily="2" charset="2"/>
+                <a:latin typeface="Arial" panose="020B0604020202020204" pitchFamily="34" charset="0"/>
+                <a:cs typeface="Arial" panose="020B0604020202020204" pitchFamily="34" charset="0"/>
               </a:rPr>
-              <a:t>(</a:t>
+              <a:t>+</a:t>
+            </a:r>
+            <a:r>
+              <a:rPr lang="el-GR" b="0" i="0" u="none" strike="noStrike" dirty="0">
+                <a:solidFill>
+                  <a:srgbClr val="333333"/>
+                </a:solidFill>
+                <a:effectLst/>
+                <a:latin typeface="Arial" panose="020B0604020202020204" pitchFamily="34" charset="0"/>
+                <a:cs typeface="Arial" panose="020B0604020202020204" pitchFamily="34" charset="0"/>
+              </a:rPr>
+              <a:t>β</a:t>
+            </a:r>
+            <a:r>
+              <a:rPr lang="el-GR" b="0" i="0" u="none" strike="noStrike" baseline="-25000" dirty="0">
+                <a:solidFill>
+                  <a:srgbClr val="333333"/>
+                </a:solidFill>
+                <a:effectLst/>
+                <a:latin typeface="Arial" panose="020B0604020202020204" pitchFamily="34" charset="0"/>
+                <a:cs typeface="Arial" panose="020B0604020202020204" pitchFamily="34" charset="0"/>
+              </a:rPr>
+              <a:t>2</a:t>
             </a:r>
             <a:r>
               <a:rPr lang="en-GB" b="0" i="0" u="none" strike="noStrike" dirty="0">
@@ -4281,9 +4349,21 @@
                   <a:srgbClr val="333333"/>
                 </a:solidFill>
                 <a:effectLst/>
-                <a:latin typeface="STIXGeneral-Italic" pitchFamily="2" charset="2"/>
+                <a:latin typeface="Arial" panose="020B0604020202020204" pitchFamily="34" charset="0"/>
+                <a:cs typeface="Arial" panose="020B0604020202020204" pitchFamily="34" charset="0"/>
               </a:rPr>
-              <a:t>t</a:t>
+              <a:t>x</a:t>
+            </a:r>
+            <a:r>
+              <a:rPr lang="en-GB" b="0" i="0" u="none" strike="noStrike" baseline="-25000" dirty="0">
+                <a:solidFill>
+                  <a:srgbClr val="333333"/>
+                </a:solidFill>
+                <a:effectLst/>
+                <a:latin typeface="Arial" panose="020B0604020202020204" pitchFamily="34" charset="0"/>
+                <a:cs typeface="Arial" panose="020B0604020202020204" pitchFamily="34" charset="0"/>
+              </a:rPr>
+              <a:t>2</a:t>
             </a:r>
             <a:r>
               <a:rPr lang="en-GB" b="0" i="0" u="none" strike="noStrike" dirty="0">
@@ -4291,9 +4371,54 @@
                   <a:srgbClr val="333333"/>
                 </a:solidFill>
                 <a:effectLst/>
-                <a:latin typeface="STIXGeneral-Regular" pitchFamily="2" charset="2"/>
+                <a:latin typeface="Arial" panose="020B0604020202020204" pitchFamily="34" charset="0"/>
+                <a:cs typeface="Arial" panose="020B0604020202020204" pitchFamily="34" charset="0"/>
               </a:rPr>
-              <a:t>))=</a:t>
+              <a:t>+...+</a:t>
+            </a:r>
+            <a:r>
+              <a:rPr lang="el-GR" b="0" i="0" u="none" strike="noStrike" dirty="0">
+                <a:solidFill>
+                  <a:srgbClr val="333333"/>
+                </a:solidFill>
+                <a:effectLst/>
+                <a:latin typeface="Arial" panose="020B0604020202020204" pitchFamily="34" charset="0"/>
+                <a:cs typeface="Arial" panose="020B0604020202020204" pitchFamily="34" charset="0"/>
+              </a:rPr>
+              <a:t>β</a:t>
+            </a:r>
+            <a:r>
+              <a:rPr lang="en-GB" b="0" i="0" u="none" strike="noStrike" baseline="-25000" dirty="0" err="1">
+                <a:solidFill>
+                  <a:srgbClr val="333333"/>
+                </a:solidFill>
+                <a:effectLst/>
+                <a:latin typeface="Arial" panose="020B0604020202020204" pitchFamily="34" charset="0"/>
+                <a:cs typeface="Arial" panose="020B0604020202020204" pitchFamily="34" charset="0"/>
+              </a:rPr>
+              <a:t>p</a:t>
+            </a:r>
+            <a:r>
+              <a:rPr lang="en-GB" b="0" i="0" u="none" strike="noStrike" dirty="0" err="1">
+                <a:solidFill>
+                  <a:srgbClr val="333333"/>
+                </a:solidFill>
+                <a:effectLst/>
+                <a:latin typeface="Arial" panose="020B0604020202020204" pitchFamily="34" charset="0"/>
+                <a:cs typeface="Arial" panose="020B0604020202020204" pitchFamily="34" charset="0"/>
+              </a:rPr>
+              <a:t>x</a:t>
+            </a:r>
+            <a:r>
+              <a:rPr lang="en-GB" b="0" i="0" u="none" strike="noStrike" baseline="-25000" dirty="0" err="1">
+                <a:solidFill>
+                  <a:srgbClr val="333333"/>
+                </a:solidFill>
+                <a:effectLst/>
+                <a:latin typeface="Arial" panose="020B0604020202020204" pitchFamily="34" charset="0"/>
+                <a:cs typeface="Arial" panose="020B0604020202020204" pitchFamily="34" charset="0"/>
+              </a:rPr>
+              <a:t>p</a:t>
             </a:r>
             <a:r>
               <a:rPr lang="en-GB" b="0" i="0" u="none" strike="noStrike" dirty="0">
@@ -4301,9 +4426,43 @@
                   <a:srgbClr val="333333"/>
                 </a:solidFill>
                 <a:effectLst/>
-                <a:latin typeface="STIXGeneral-Italic" pitchFamily="2" charset="2"/>
+                <a:latin typeface="Arial" panose="020B0604020202020204" pitchFamily="34" charset="0"/>
+                <a:cs typeface="Arial" panose="020B0604020202020204" pitchFamily="34" charset="0"/>
               </a:rPr>
-              <a:t>log</a:t>
+              <a:t>.</a:t>
+            </a:r>
+            <a:br>
+              <a:rPr lang="en-GB" dirty="0">
+                <a:latin typeface="Arial" panose="020B0604020202020204" pitchFamily="34" charset="0"/>
+                <a:cs typeface="Arial" panose="020B0604020202020204" pitchFamily="34" charset="0"/>
+              </a:rPr>
+            </a:br>
+            <a:endParaRPr lang="en-GB" dirty="0">
+              <a:latin typeface="Arial" panose="020B0604020202020204" pitchFamily="34" charset="0"/>
+              <a:cs typeface="Arial" panose="020B0604020202020204" pitchFamily="34" charset="0"/>
+            </a:endParaRPr>
+          </a:p>
+          <a:p>
+            <a:r>
+              <a:rPr lang="en-GB" dirty="0">
+                <a:solidFill>
+                  <a:srgbClr val="333333"/>
+                </a:solidFill>
+                <a:latin typeface="Arial" panose="020B0604020202020204" pitchFamily="34" charset="0"/>
+                <a:cs typeface="Arial" panose="020B0604020202020204" pitchFamily="34" charset="0"/>
+              </a:rPr>
+              <a:t>M</a:t>
+            </a:r>
+            <a:r>
+              <a:rPr lang="en-GB" b="0" i="0" dirty="0">
+                <a:solidFill>
+                  <a:srgbClr val="333333"/>
+                </a:solidFill>
+                <a:effectLst/>
+                <a:latin typeface="Arial" panose="020B0604020202020204" pitchFamily="34" charset="0"/>
+                <a:cs typeface="Arial" panose="020B0604020202020204" pitchFamily="34" charset="0"/>
+              </a:rPr>
+              <a:t>ultiple exposure variables </a:t>
             </a:r>
             <a:r>
               <a:rPr lang="en-GB" b="0" i="0" u="none" strike="noStrike" dirty="0">
@@ -4311,9 +4470,21 @@
                   <a:srgbClr val="333333"/>
                 </a:solidFill>
                 <a:effectLst/>
-                <a:latin typeface="STIXGeneral-Regular" pitchFamily="2" charset="2"/>
+                <a:latin typeface="Arial" panose="020B0604020202020204" pitchFamily="34" charset="0"/>
+                <a:cs typeface="Arial" panose="020B0604020202020204" pitchFamily="34" charset="0"/>
               </a:rPr>
-              <a:t>(</a:t>
+              <a:t>x</a:t>
+            </a:r>
+            <a:r>
+              <a:rPr lang="en-GB" b="0" i="0" u="none" strike="noStrike" baseline="-25000" dirty="0">
+                <a:solidFill>
+                  <a:srgbClr val="333333"/>
+                </a:solidFill>
+                <a:effectLst/>
+                <a:latin typeface="Arial" panose="020B0604020202020204" pitchFamily="34" charset="0"/>
+                <a:cs typeface="Arial" panose="020B0604020202020204" pitchFamily="34" charset="0"/>
+              </a:rPr>
+              <a:t>1</a:t>
             </a:r>
             <a:r>
               <a:rPr lang="en-GB" b="0" i="0" u="none" strike="noStrike" dirty="0">
@@ -4321,9 +4492,10 @@
                   <a:srgbClr val="333333"/>
                 </a:solidFill>
                 <a:effectLst/>
-                <a:latin typeface="STIXGeneral-Italic" pitchFamily="2" charset="2"/>
+                <a:latin typeface="Arial" panose="020B0604020202020204" pitchFamily="34" charset="0"/>
+                <a:cs typeface="Arial" panose="020B0604020202020204" pitchFamily="34" charset="0"/>
               </a:rPr>
-              <a:t>h</a:t>
+              <a:t>, x</a:t>
             </a:r>
             <a:r>
               <a:rPr lang="en-GB" b="0" i="0" u="none" strike="noStrike" baseline="-25000" dirty="0">
@@ -4331,9 +4503,10 @@
                   <a:srgbClr val="333333"/>
                 </a:solidFill>
                 <a:effectLst/>
-                <a:latin typeface="STIXGeneral-Regular" pitchFamily="2" charset="2"/>
+                <a:latin typeface="Arial" panose="020B0604020202020204" pitchFamily="34" charset="0"/>
+                <a:cs typeface="Arial" panose="020B0604020202020204" pitchFamily="34" charset="0"/>
               </a:rPr>
-              <a:t>0</a:t>
+              <a:t>2</a:t>
             </a:r>
             <a:r>
               <a:rPr lang="en-GB" b="0" i="0" u="none" strike="noStrike" dirty="0">
@@ -4341,49 +4514,110 @@
                   <a:srgbClr val="333333"/>
                 </a:solidFill>
                 <a:effectLst/>
-                <a:latin typeface="STIXGeneral-Regular" pitchFamily="2" charset="2"/>
+                <a:latin typeface="Arial" panose="020B0604020202020204" pitchFamily="34" charset="0"/>
+                <a:cs typeface="Arial" panose="020B0604020202020204" pitchFamily="34" charset="0"/>
               </a:rPr>
-              <a:t>(</a:t>
-            </a:r>
+              <a:t>, …, </a:t>
+            </a:r>
+            <a:r>
+              <a:rPr lang="en-GB" b="0" i="0" u="none" strike="noStrike" dirty="0" err="1">
+                <a:solidFill>
+                  <a:srgbClr val="333333"/>
+                </a:solidFill>
+                <a:effectLst/>
+                <a:latin typeface="Arial" panose="020B0604020202020204" pitchFamily="34" charset="0"/>
+                <a:cs typeface="Arial" panose="020B0604020202020204" pitchFamily="34" charset="0"/>
+              </a:rPr>
+              <a:t>x</a:t>
+            </a:r>
+            <a:r>
+              <a:rPr lang="en-GB" b="0" i="0" u="none" strike="noStrike" baseline="-25000" dirty="0" err="1">
+                <a:solidFill>
+                  <a:srgbClr val="333333"/>
+                </a:solidFill>
+                <a:effectLst/>
+                <a:latin typeface="Arial" panose="020B0604020202020204" pitchFamily="34" charset="0"/>
+                <a:cs typeface="Arial" panose="020B0604020202020204" pitchFamily="34" charset="0"/>
+              </a:rPr>
+              <a:t>p</a:t>
+            </a:r>
+            <a:endParaRPr lang="en-GB" b="0" i="0" u="none" strike="noStrike" baseline="-25000" dirty="0">
+              <a:solidFill>
+                <a:srgbClr val="333333"/>
+              </a:solidFill>
+              <a:effectLst/>
+              <a:latin typeface="Arial" panose="020B0604020202020204" pitchFamily="34" charset="0"/>
+              <a:cs typeface="Arial" panose="020B0604020202020204" pitchFamily="34" charset="0"/>
+            </a:endParaRPr>
+          </a:p>
+          <a:p>
             <a:r>
               <a:rPr lang="en-GB" b="0" i="0" u="none" strike="noStrike" dirty="0">
                 <a:solidFill>
                   <a:srgbClr val="333333"/>
                 </a:solidFill>
                 <a:effectLst/>
-                <a:latin typeface="STIXGeneral-Italic" pitchFamily="2" charset="2"/>
+                <a:latin typeface="Arial" panose="020B0604020202020204" pitchFamily="34" charset="0"/>
+                <a:cs typeface="Arial" panose="020B0604020202020204" pitchFamily="34" charset="0"/>
+              </a:rPr>
+              <a:t>h(t) = hazard at time </a:t>
+            </a:r>
+            <a:r>
+              <a:rPr lang="en-GB" b="0" i="1" u="none" strike="noStrike" dirty="0">
+                <a:solidFill>
+                  <a:srgbClr val="333333"/>
+                </a:solidFill>
+                <a:effectLst/>
+                <a:latin typeface="Arial" panose="020B0604020202020204" pitchFamily="34" charset="0"/>
+                <a:cs typeface="Arial" panose="020B0604020202020204" pitchFamily="34" charset="0"/>
               </a:rPr>
               <a:t>t</a:t>
             </a:r>
+            <a:r>
+              <a:rPr lang="en-GB" b="0" u="none" strike="noStrike" dirty="0">
+                <a:solidFill>
+                  <a:srgbClr val="333333"/>
+                </a:solidFill>
+                <a:effectLst/>
+                <a:latin typeface="Arial" panose="020B0604020202020204" pitchFamily="34" charset="0"/>
+                <a:cs typeface="Arial" panose="020B0604020202020204" pitchFamily="34" charset="0"/>
+              </a:rPr>
+              <a:t>  i.e. the likelihood an event will occur at time </a:t>
+            </a:r>
+            <a:r>
+              <a:rPr lang="en-GB" b="0" i="1" u="none" strike="noStrike" dirty="0">
+                <a:solidFill>
+                  <a:srgbClr val="333333"/>
+                </a:solidFill>
+                <a:effectLst/>
+                <a:latin typeface="Arial" panose="020B0604020202020204" pitchFamily="34" charset="0"/>
+                <a:cs typeface="Arial" panose="020B0604020202020204" pitchFamily="34" charset="0"/>
+              </a:rPr>
+              <a:t>t</a:t>
+            </a:r>
+          </a:p>
+          <a:p>
             <a:r>
               <a:rPr lang="en-GB" b="0" i="0" u="none" strike="noStrike" dirty="0">
                 <a:solidFill>
                   <a:srgbClr val="333333"/>
                 </a:solidFill>
                 <a:effectLst/>
-                <a:latin typeface="STIXGeneral-Regular" pitchFamily="2" charset="2"/>
+                <a:latin typeface="Arial" panose="020B0604020202020204" pitchFamily="34" charset="0"/>
+                <a:cs typeface="Arial" panose="020B0604020202020204" pitchFamily="34" charset="0"/>
               </a:rPr>
-              <a:t>))+</a:t>
-            </a:r>
-            <a:r>
-              <a:rPr lang="el-GR" b="0" i="0" u="none" strike="noStrike" dirty="0">
+              <a:t>h</a:t>
+            </a:r>
+            <a:r>
+              <a:rPr lang="en-GB" b="0" i="0" u="none" strike="noStrike" baseline="-25000" dirty="0">
                 <a:solidFill>
                   <a:srgbClr val="333333"/>
                 </a:solidFill>
                 <a:effectLst/>
-                <a:latin typeface="STIXGeneral-Italic" pitchFamily="2" charset="2"/>
+                <a:latin typeface="Arial" panose="020B0604020202020204" pitchFamily="34" charset="0"/>
+                <a:cs typeface="Arial" panose="020B0604020202020204" pitchFamily="34" charset="0"/>
               </a:rPr>
-              <a:t>β</a:t>
-            </a:r>
-            <a:r>
-              <a:rPr lang="el-GR" b="0" i="0" u="none" strike="noStrike" baseline="-25000" dirty="0">
-                <a:solidFill>
-                  <a:srgbClr val="333333"/>
-                </a:solidFill>
-                <a:effectLst/>
-                <a:latin typeface="STIXGeneral-Regular" pitchFamily="2" charset="2"/>
-              </a:rPr>
-              <a:t>1</a:t>
+              <a:t>0</a:t>
             </a:r>
             <a:r>
               <a:rPr lang="en-GB" b="0" i="0" u="none" strike="noStrike" dirty="0">
@@ -4391,372 +4625,18 @@
                   <a:srgbClr val="333333"/>
                 </a:solidFill>
                 <a:effectLst/>
-                <a:latin typeface="STIXGeneral-Italic" pitchFamily="2" charset="2"/>
+                <a:latin typeface="Arial" panose="020B0604020202020204" pitchFamily="34" charset="0"/>
+                <a:cs typeface="Arial" panose="020B0604020202020204" pitchFamily="34" charset="0"/>
               </a:rPr>
-              <a:t>x</a:t>
-            </a:r>
-            <a:r>
-              <a:rPr lang="en-GB" b="0" i="0" u="none" strike="noStrike" baseline="-25000" dirty="0">
-                <a:solidFill>
-                  <a:srgbClr val="333333"/>
-                </a:solidFill>
-                <a:effectLst/>
-                <a:latin typeface="STIXGeneral-Regular" pitchFamily="2" charset="2"/>
-              </a:rPr>
-              <a:t>1</a:t>
-            </a:r>
-            <a:r>
-              <a:rPr lang="en-GB" b="0" i="0" u="none" strike="noStrike" dirty="0">
-                <a:solidFill>
-                  <a:srgbClr val="333333"/>
-                </a:solidFill>
-                <a:effectLst/>
-                <a:latin typeface="STIXGeneral-Regular" pitchFamily="2" charset="2"/>
-              </a:rPr>
-              <a:t>+</a:t>
-            </a:r>
-            <a:r>
-              <a:rPr lang="el-GR" b="0" i="0" u="none" strike="noStrike" dirty="0">
-                <a:solidFill>
-                  <a:srgbClr val="333333"/>
-                </a:solidFill>
-                <a:effectLst/>
-                <a:latin typeface="STIXGeneral-Italic" pitchFamily="2" charset="2"/>
-              </a:rPr>
-              <a:t>β</a:t>
-            </a:r>
-            <a:r>
-              <a:rPr lang="el-GR" b="0" i="0" u="none" strike="noStrike" baseline="-25000" dirty="0">
-                <a:solidFill>
-                  <a:srgbClr val="333333"/>
-                </a:solidFill>
-                <a:effectLst/>
-                <a:latin typeface="STIXGeneral-Regular" pitchFamily="2" charset="2"/>
-              </a:rPr>
-              <a:t>2</a:t>
-            </a:r>
-            <a:r>
-              <a:rPr lang="en-GB" b="0" i="0" u="none" strike="noStrike" dirty="0">
-                <a:solidFill>
-                  <a:srgbClr val="333333"/>
-                </a:solidFill>
-                <a:effectLst/>
-                <a:latin typeface="STIXGeneral-Italic" pitchFamily="2" charset="2"/>
-              </a:rPr>
-              <a:t>x</a:t>
-            </a:r>
-            <a:r>
-              <a:rPr lang="en-GB" b="0" i="0" u="none" strike="noStrike" baseline="-25000" dirty="0">
-                <a:solidFill>
-                  <a:srgbClr val="333333"/>
-                </a:solidFill>
-                <a:effectLst/>
-                <a:latin typeface="STIXGeneral-Regular" pitchFamily="2" charset="2"/>
-              </a:rPr>
-              <a:t>2</a:t>
-            </a:r>
-            <a:r>
-              <a:rPr lang="en-GB" b="0" i="0" u="none" strike="noStrike" dirty="0">
-                <a:solidFill>
-                  <a:srgbClr val="333333"/>
-                </a:solidFill>
-                <a:effectLst/>
-                <a:latin typeface="STIXGeneral-Regular" pitchFamily="2" charset="2"/>
-              </a:rPr>
-              <a:t>+...+</a:t>
-            </a:r>
-            <a:r>
-              <a:rPr lang="el-GR" b="0" i="0" u="none" strike="noStrike" dirty="0">
-                <a:solidFill>
-                  <a:srgbClr val="333333"/>
-                </a:solidFill>
-                <a:effectLst/>
-                <a:latin typeface="STIXGeneral-Italic" pitchFamily="2" charset="2"/>
-              </a:rPr>
-              <a:t>β</a:t>
-            </a:r>
-            <a:r>
-              <a:rPr lang="en-GB" b="0" i="0" u="none" strike="noStrike" baseline="-25000" dirty="0" err="1">
-                <a:solidFill>
-                  <a:srgbClr val="333333"/>
-                </a:solidFill>
-                <a:effectLst/>
-                <a:latin typeface="STIXGeneral-Italic" pitchFamily="2" charset="2"/>
-              </a:rPr>
-              <a:t>p</a:t>
-            </a:r>
-            <a:r>
-              <a:rPr lang="en-GB" b="0" i="0" u="none" strike="noStrike" dirty="0" err="1">
-                <a:solidFill>
-                  <a:srgbClr val="333333"/>
-                </a:solidFill>
-                <a:effectLst/>
-                <a:latin typeface="STIXGeneral-Italic" pitchFamily="2" charset="2"/>
-              </a:rPr>
-              <a:t>x</a:t>
-            </a:r>
-            <a:r>
-              <a:rPr lang="en-GB" b="0" i="0" u="none" strike="noStrike" baseline="-25000" dirty="0" err="1">
-                <a:solidFill>
-                  <a:srgbClr val="333333"/>
-                </a:solidFill>
-                <a:effectLst/>
-                <a:latin typeface="STIXGeneral-Italic" pitchFamily="2" charset="2"/>
-              </a:rPr>
-              <a:t>p</a:t>
-            </a:r>
-            <a:r>
-              <a:rPr lang="en-GB" b="0" i="0" u="none" strike="noStrike" dirty="0">
-                <a:solidFill>
-                  <a:srgbClr val="333333"/>
-                </a:solidFill>
-                <a:effectLst/>
-                <a:latin typeface="STIXGeneral-Regular" pitchFamily="2" charset="2"/>
-              </a:rPr>
-              <a:t>.</a:t>
-            </a:r>
-            <a:br>
-              <a:rPr lang="en-GB" dirty="0"/>
-            </a:br>
-            <a:endParaRPr lang="en-GB" dirty="0"/>
-          </a:p>
-          <a:p>
-            <a:r>
-              <a:rPr lang="en-GB" dirty="0">
-                <a:solidFill>
-                  <a:srgbClr val="333333"/>
-                </a:solidFill>
-                <a:latin typeface="Helvetica Neue" panose="02000503000000020004" pitchFamily="2" charset="0"/>
-              </a:rPr>
-              <a:t>M</a:t>
-            </a:r>
-            <a:r>
-              <a:rPr lang="en-GB" b="0" i="0" dirty="0">
-                <a:solidFill>
-                  <a:srgbClr val="333333"/>
-                </a:solidFill>
-                <a:effectLst/>
-                <a:latin typeface="Helvetica Neue" panose="02000503000000020004" pitchFamily="2" charset="0"/>
-              </a:rPr>
-              <a:t>ultiple exposure variables </a:t>
-            </a:r>
-            <a:r>
-              <a:rPr lang="en-GB" b="0" i="0" u="none" strike="noStrike" dirty="0">
-                <a:solidFill>
-                  <a:srgbClr val="333333"/>
-                </a:solidFill>
-                <a:effectLst/>
-                <a:latin typeface="STIXGeneral-Italic" pitchFamily="2" charset="2"/>
-              </a:rPr>
-              <a:t>x</a:t>
-            </a:r>
-            <a:r>
-              <a:rPr lang="en-GB" b="0" i="0" u="none" strike="noStrike" baseline="-25000" dirty="0">
-                <a:solidFill>
-                  <a:srgbClr val="333333"/>
-                </a:solidFill>
-                <a:effectLst/>
-                <a:latin typeface="STIXGeneral-Regular" pitchFamily="2" charset="2"/>
-              </a:rPr>
-              <a:t>1</a:t>
-            </a:r>
-            <a:r>
-              <a:rPr lang="en-GB" b="0" i="0" u="none" strike="noStrike" dirty="0">
-                <a:solidFill>
-                  <a:srgbClr val="333333"/>
-                </a:solidFill>
-                <a:effectLst/>
-                <a:latin typeface="STIXGeneral-Regular" pitchFamily="2" charset="2"/>
-              </a:rPr>
-              <a:t>, </a:t>
-            </a:r>
-            <a:r>
-              <a:rPr lang="en-GB" b="0" i="0" u="none" strike="noStrike" dirty="0">
-                <a:solidFill>
-                  <a:srgbClr val="333333"/>
-                </a:solidFill>
-                <a:effectLst/>
-                <a:latin typeface="STIXGeneral-Italic" pitchFamily="2" charset="2"/>
-              </a:rPr>
-              <a:t>x</a:t>
-            </a:r>
-            <a:r>
-              <a:rPr lang="en-GB" b="0" i="0" u="none" strike="noStrike" baseline="-25000" dirty="0">
-                <a:solidFill>
-                  <a:srgbClr val="333333"/>
-                </a:solidFill>
-                <a:effectLst/>
-                <a:latin typeface="STIXGeneral-Regular" pitchFamily="2" charset="2"/>
-              </a:rPr>
-              <a:t>2</a:t>
-            </a:r>
-            <a:r>
-              <a:rPr lang="en-GB" b="0" i="0" u="none" strike="noStrike" dirty="0">
-                <a:solidFill>
-                  <a:srgbClr val="333333"/>
-                </a:solidFill>
-                <a:effectLst/>
-                <a:latin typeface="STIXGeneral-Regular" pitchFamily="2" charset="2"/>
-              </a:rPr>
-              <a:t>, …, </a:t>
-            </a:r>
-            <a:r>
-              <a:rPr lang="en-GB" b="0" i="0" u="none" strike="noStrike" dirty="0" err="1">
-                <a:solidFill>
-                  <a:srgbClr val="333333"/>
-                </a:solidFill>
-                <a:effectLst/>
-                <a:latin typeface="STIXGeneral-Italic" pitchFamily="2" charset="2"/>
-              </a:rPr>
-              <a:t>x</a:t>
-            </a:r>
-            <a:r>
-              <a:rPr lang="en-GB" b="0" i="0" u="none" strike="noStrike" baseline="-25000" dirty="0" err="1">
-                <a:solidFill>
-                  <a:srgbClr val="333333"/>
-                </a:solidFill>
-                <a:effectLst/>
-                <a:latin typeface="STIXGeneral-Italic" pitchFamily="2" charset="2"/>
-              </a:rPr>
-              <a:t>p</a:t>
-            </a:r>
-            <a:endParaRPr lang="en-GB" b="0" i="0" u="none" strike="noStrike" baseline="-25000" dirty="0">
-              <a:solidFill>
-                <a:srgbClr val="333333"/>
-              </a:solidFill>
-              <a:effectLst/>
-              <a:latin typeface="STIXGeneral-Italic" pitchFamily="2" charset="2"/>
-            </a:endParaRPr>
-          </a:p>
-          <a:p>
-            <a:r>
-              <a:rPr lang="en-GB" b="0" i="0" u="none" strike="noStrike" dirty="0">
-                <a:solidFill>
-                  <a:srgbClr val="333333"/>
-                </a:solidFill>
-                <a:effectLst/>
-                <a:latin typeface="STIXGeneral-Italic" pitchFamily="2" charset="2"/>
-              </a:rPr>
-              <a:t>h</a:t>
-            </a:r>
-            <a:r>
-              <a:rPr lang="en-GB" b="0" i="0" u="none" strike="noStrike" dirty="0">
-                <a:solidFill>
-                  <a:srgbClr val="333333"/>
-                </a:solidFill>
-                <a:effectLst/>
-                <a:latin typeface="STIXGeneral-Regular" pitchFamily="2" charset="2"/>
-              </a:rPr>
-              <a:t>(</a:t>
-            </a:r>
-            <a:r>
-              <a:rPr lang="en-GB" b="0" i="0" u="none" strike="noStrike" dirty="0">
-                <a:solidFill>
-                  <a:srgbClr val="333333"/>
-                </a:solidFill>
-                <a:effectLst/>
-                <a:latin typeface="STIXGeneral-Italic" pitchFamily="2" charset="2"/>
-              </a:rPr>
-              <a:t>t</a:t>
-            </a:r>
-            <a:r>
-              <a:rPr lang="en-GB" b="0" i="0" u="none" strike="noStrike" dirty="0">
-                <a:solidFill>
-                  <a:srgbClr val="333333"/>
-                </a:solidFill>
-                <a:effectLst/>
-                <a:latin typeface="STIXGeneral-Regular" pitchFamily="2" charset="2"/>
-              </a:rPr>
-              <a:t>) = hazard at time </a:t>
-            </a:r>
-            <a:r>
-              <a:rPr lang="en-GB" b="0" i="1" u="none" strike="noStrike" dirty="0">
-                <a:solidFill>
-                  <a:srgbClr val="333333"/>
-                </a:solidFill>
-                <a:effectLst/>
-                <a:latin typeface="STIXGeneral-Regular" pitchFamily="2" charset="2"/>
-              </a:rPr>
-              <a:t>t</a:t>
-            </a:r>
-            <a:r>
-              <a:rPr lang="en-GB" b="0" u="none" strike="noStrike" dirty="0">
-                <a:solidFill>
-                  <a:srgbClr val="333333"/>
-                </a:solidFill>
-                <a:effectLst/>
-                <a:latin typeface="STIXGeneral-Regular" pitchFamily="2" charset="2"/>
-              </a:rPr>
-              <a:t>  i.e. the likelihood an event will occur at time </a:t>
-            </a:r>
-            <a:r>
-              <a:rPr lang="en-GB" b="0" i="1" u="none" strike="noStrike" dirty="0">
-                <a:solidFill>
-                  <a:srgbClr val="333333"/>
-                </a:solidFill>
-                <a:effectLst/>
-                <a:latin typeface="STIXGeneral-Regular" pitchFamily="2" charset="2"/>
-              </a:rPr>
-              <a:t>t</a:t>
-            </a:r>
-          </a:p>
-          <a:p>
-            <a:r>
-              <a:rPr lang="en-GB" b="0" i="0" u="none" strike="noStrike" dirty="0">
-                <a:solidFill>
-                  <a:srgbClr val="333333"/>
-                </a:solidFill>
-                <a:effectLst/>
-                <a:latin typeface="STIXGeneral-Italic" pitchFamily="2" charset="2"/>
-              </a:rPr>
-              <a:t>h</a:t>
-            </a:r>
-            <a:r>
-              <a:rPr lang="en-GB" b="0" i="0" u="none" strike="noStrike" baseline="-25000" dirty="0">
-                <a:solidFill>
-                  <a:srgbClr val="333333"/>
-                </a:solidFill>
-                <a:effectLst/>
-                <a:latin typeface="STIXGeneral-Regular" pitchFamily="2" charset="2"/>
-              </a:rPr>
-              <a:t>0</a:t>
-            </a:r>
-            <a:r>
-              <a:rPr lang="en-GB" b="0" i="0" u="none" strike="noStrike" dirty="0">
-                <a:solidFill>
-                  <a:srgbClr val="333333"/>
-                </a:solidFill>
-                <a:effectLst/>
-                <a:latin typeface="STIXGeneral-Regular" pitchFamily="2" charset="2"/>
-              </a:rPr>
-              <a:t>(</a:t>
-            </a:r>
-            <a:r>
-              <a:rPr lang="en-GB" b="0" i="0" u="none" strike="noStrike" dirty="0">
-                <a:solidFill>
-                  <a:srgbClr val="333333"/>
-                </a:solidFill>
-                <a:effectLst/>
-                <a:latin typeface="STIXGeneral-Italic" pitchFamily="2" charset="2"/>
-              </a:rPr>
-              <a:t>t</a:t>
-            </a:r>
-            <a:r>
-              <a:rPr lang="en-GB" b="0" i="0" u="none" strike="noStrike" dirty="0">
-                <a:solidFill>
-                  <a:srgbClr val="333333"/>
-                </a:solidFill>
-                <a:effectLst/>
-                <a:latin typeface="STIXGeneral-Regular" pitchFamily="2" charset="2"/>
-              </a:rPr>
-              <a:t>) = baseline hazard (hazard for an individual when all exposure variables are 0)</a:t>
+              <a:t>(t) = baseline hazard (hazard for an individual when all exposure variables are 0)</a:t>
             </a:r>
             <a:endParaRPr lang="en-GB" b="0" i="1" u="none" strike="noStrike" dirty="0">
               <a:solidFill>
                 <a:srgbClr val="333333"/>
               </a:solidFill>
               <a:effectLst/>
-              <a:latin typeface="STIXGeneral-Regular" pitchFamily="2" charset="2"/>
+              <a:latin typeface="Arial" panose="020B0604020202020204" pitchFamily="34" charset="0"/>
+              <a:cs typeface="Arial" panose="020B0604020202020204" pitchFamily="34" charset="0"/>
             </a:endParaRPr>
           </a:p>
         </p:txBody>
@@ -4837,7 +4717,9 @@
         </p:nvSpPr>
         <p:spPr/>
         <p:txBody>
-          <a:bodyPr/>
+          <a:bodyPr>
+            <a:normAutofit lnSpcReduction="10000"/>
+          </a:bodyPr>
           <a:lstStyle/>
           <a:p>
             <a:pPr marL="0" indent="0">
@@ -4911,7 +4793,7 @@
                 <a:effectLst/>
                 <a:latin typeface="Open Sans" panose="020B0606030504020204" pitchFamily="34" charset="0"/>
               </a:rPr>
-              <a:t>HR &lt; 1: Reduction in the hazard (a bad prognostic factor)</a:t>
+              <a:t>HR &lt; 1: Reduction in the hazard (a prognostic factor for a good outcome)</a:t>
             </a:r>
           </a:p>
           <a:p>
@@ -4927,7 +4809,7 @@
                 <a:effectLst/>
                 <a:latin typeface="Open Sans" panose="020B0606030504020204" pitchFamily="34" charset="0"/>
               </a:rPr>
-              <a:t>HR &gt; 1: Increase in hazard (a good prognostic factor)</a:t>
+              <a:t>HR &gt; 1: Increase in hazard (a prognostic factor for a bad outcome)</a:t>
             </a:r>
           </a:p>
           <a:p>

</xml_diff>